<commit_message>
Update presentation deck to the 11-slide version
Replace the PPTX, PDF and slide previews shown on the landing page,
and extend the slide viewer from 10 to 11 slides.
</commit_message>
<xml_diff>
--- a/frontend/public/Multi-Document-RAG-with-Citations.pptx
+++ b/frontend/public/Multi-Document-RAG-with-Citations.pptx
@@ -1,29 +1,31 @@
 
 <file path=ppt/presentation.xml><?xml version="1.0" encoding="utf-8"?>
-<p:presentation xmlns:a="http://schemas.openxmlformats.org/drawingml/2006/main" xmlns:r="http://schemas.openxmlformats.org/officeDocument/2006/relationships" xmlns:p="http://schemas.openxmlformats.org/presentationml/2006/main" saveSubsetFonts="1" autoCompressPictures="0">
+<p:presentation xmlns:a="http://schemas.openxmlformats.org/drawingml/2006/main" xmlns:r="http://schemas.openxmlformats.org/officeDocument/2006/relationships" xmlns:mc="http://schemas.openxmlformats.org/markup-compatibility/2006" xmlns:mv="urn:schemas-microsoft-com:mac:vml" xmlns:p="http://schemas.openxmlformats.org/presentationml/2006/main" xmlns:c="http://schemas.openxmlformats.org/drawingml/2006/chart" xmlns:dgm="http://schemas.openxmlformats.org/drawingml/2006/diagram" xmlns:o="urn:schemas-microsoft-com:office:office" xmlns:v="urn:schemas-microsoft-com:vml" xmlns:pvml="urn:schemas-microsoft-com:office:powerpoint" xmlns:com="http://schemas.openxmlformats.org/drawingml/2006/compatibility" xmlns:p14="http://schemas.microsoft.com/office/powerpoint/2010/main" xmlns:p15="http://schemas.microsoft.com/office/powerpoint/2012/main" xmlns:ahyp="http://schemas.microsoft.com/office/drawing/2018/hyperlinkcolor" autoCompressPictures="0" strictFirstAndLastChars="0" saveSubsetFonts="1">
   <p:sldMasterIdLst>
-    <p:sldMasterId id="2147483648" r:id="rId1"/>
+    <p:sldMasterId id="2147483648" r:id="rId3"/>
   </p:sldMasterIdLst>
   <p:notesMasterIdLst>
-    <p:notesMasterId r:id="rId12"/>
+    <p:notesMasterId r:id="rId4"/>
   </p:notesMasterIdLst>
   <p:sldIdLst>
-    <p:sldId id="256" r:id="rId2"/>
-    <p:sldId id="257" r:id="rId3"/>
-    <p:sldId id="258" r:id="rId4"/>
-    <p:sldId id="259" r:id="rId5"/>
-    <p:sldId id="260" r:id="rId6"/>
-    <p:sldId id="261" r:id="rId7"/>
-    <p:sldId id="262" r:id="rId8"/>
-    <p:sldId id="263" r:id="rId9"/>
-    <p:sldId id="264" r:id="rId10"/>
-    <p:sldId id="265" r:id="rId11"/>
+    <p:sldId id="256" r:id="rId5"/>
+    <p:sldId id="257" r:id="rId6"/>
+    <p:sldId id="258" r:id="rId7"/>
+    <p:sldId id="259" r:id="rId8"/>
+    <p:sldId id="260" r:id="rId9"/>
+    <p:sldId id="261" r:id="rId10"/>
+    <p:sldId id="262" r:id="rId11"/>
+    <p:sldId id="263" r:id="rId12"/>
+    <p:sldId id="264" r:id="rId13"/>
+    <p:sldId id="266" r:id="rId15"/>
+    <p:sldId id="265" r:id="rId14"/>
   </p:sldIdLst>
-  <p:sldSz cx="12192000" cy="6858000"/>
+  <p:sldSz cy="6858000" cx="12192000"/>
   <p:notesSz cx="6858000" cy="12192000"/>
   <p:defaultTextStyle>
-    <a:lvl1pPr marL="0" algn="l" defTabSz="914400" rtl="0" eaLnBrk="1" latinLnBrk="0" hangingPunct="1">
-      <a:defRPr sz="1800" kern="1200">
+    <a:defPPr lvl="0"/>
+    <a:lvl1pPr defTabSz="914400" eaLnBrk="1" hangingPunct="1" latinLnBrk="0" lvl="0" marL="0" rtl="0" algn="l">
+      <a:defRPr kern="1200" sz="1800">
         <a:solidFill>
           <a:schemeClr val="tx1"/>
         </a:solidFill>
@@ -32,8 +34,8 @@
         <a:cs typeface="+mn-cs"/>
       </a:defRPr>
     </a:lvl1pPr>
-    <a:lvl2pPr marL="457200" algn="l" defTabSz="914400" rtl="0" eaLnBrk="1" latinLnBrk="0" hangingPunct="1">
-      <a:defRPr sz="1800" kern="1200">
+    <a:lvl2pPr defTabSz="914400" eaLnBrk="1" hangingPunct="1" latinLnBrk="0" lvl="1" marL="457200" rtl="0" algn="l">
+      <a:defRPr kern="1200" sz="1800">
         <a:solidFill>
           <a:schemeClr val="tx1"/>
         </a:solidFill>
@@ -42,8 +44,8 @@
         <a:cs typeface="+mn-cs"/>
       </a:defRPr>
     </a:lvl2pPr>
-    <a:lvl3pPr marL="914400" algn="l" defTabSz="914400" rtl="0" eaLnBrk="1" latinLnBrk="0" hangingPunct="1">
-      <a:defRPr sz="1800" kern="1200">
+    <a:lvl3pPr defTabSz="914400" eaLnBrk="1" hangingPunct="1" latinLnBrk="0" lvl="2" marL="914400" rtl="0" algn="l">
+      <a:defRPr kern="1200" sz="1800">
         <a:solidFill>
           <a:schemeClr val="tx1"/>
         </a:solidFill>
@@ -52,8 +54,8 @@
         <a:cs typeface="+mn-cs"/>
       </a:defRPr>
     </a:lvl3pPr>
-    <a:lvl4pPr marL="1371600" algn="l" defTabSz="914400" rtl="0" eaLnBrk="1" latinLnBrk="0" hangingPunct="1">
-      <a:defRPr sz="1800" kern="1200">
+    <a:lvl4pPr defTabSz="914400" eaLnBrk="1" hangingPunct="1" latinLnBrk="0" lvl="3" marL="1371600" rtl="0" algn="l">
+      <a:defRPr kern="1200" sz="1800">
         <a:solidFill>
           <a:schemeClr val="tx1"/>
         </a:solidFill>
@@ -62,8 +64,8 @@
         <a:cs typeface="+mn-cs"/>
       </a:defRPr>
     </a:lvl4pPr>
-    <a:lvl5pPr marL="1828800" algn="l" defTabSz="914400" rtl="0" eaLnBrk="1" latinLnBrk="0" hangingPunct="1">
-      <a:defRPr sz="1800" kern="1200">
+    <a:lvl5pPr defTabSz="914400" eaLnBrk="1" hangingPunct="1" latinLnBrk="0" lvl="4" marL="1828800" rtl="0" algn="l">
+      <a:defRPr kern="1200" sz="1800">
         <a:solidFill>
           <a:schemeClr val="tx1"/>
         </a:solidFill>
@@ -72,8 +74,8 @@
         <a:cs typeface="+mn-cs"/>
       </a:defRPr>
     </a:lvl5pPr>
-    <a:lvl6pPr marL="2286000" algn="l" defTabSz="914400" rtl="0" eaLnBrk="1" latinLnBrk="0" hangingPunct="1">
-      <a:defRPr sz="1800" kern="1200">
+    <a:lvl6pPr defTabSz="914400" eaLnBrk="1" hangingPunct="1" latinLnBrk="0" lvl="5" marL="2286000" rtl="0" algn="l">
+      <a:defRPr kern="1200" sz="1800">
         <a:solidFill>
           <a:schemeClr val="tx1"/>
         </a:solidFill>
@@ -82,8 +84,8 @@
         <a:cs typeface="+mn-cs"/>
       </a:defRPr>
     </a:lvl6pPr>
-    <a:lvl7pPr marL="2743200" algn="l" defTabSz="914400" rtl="0" eaLnBrk="1" latinLnBrk="0" hangingPunct="1">
-      <a:defRPr sz="1800" kern="1200">
+    <a:lvl7pPr defTabSz="914400" eaLnBrk="1" hangingPunct="1" latinLnBrk="0" lvl="6" marL="2743200" rtl="0" algn="l">
+      <a:defRPr kern="1200" sz="1800">
         <a:solidFill>
           <a:schemeClr val="tx1"/>
         </a:solidFill>
@@ -92,8 +94,8 @@
         <a:cs typeface="+mn-cs"/>
       </a:defRPr>
     </a:lvl7pPr>
-    <a:lvl8pPr marL="3200400" algn="l" defTabSz="914400" rtl="0" eaLnBrk="1" latinLnBrk="0" hangingPunct="1">
-      <a:defRPr sz="1800" kern="1200">
+    <a:lvl8pPr defTabSz="914400" eaLnBrk="1" hangingPunct="1" latinLnBrk="0" lvl="7" marL="3200400" rtl="0" algn="l">
+      <a:defRPr kern="1200" sz="1800">
         <a:solidFill>
           <a:schemeClr val="tx1"/>
         </a:solidFill>
@@ -102,8 +104,8 @@
         <a:cs typeface="+mn-cs"/>
       </a:defRPr>
     </a:lvl8pPr>
-    <a:lvl9pPr marL="3657600" algn="l" defTabSz="914400" rtl="0" eaLnBrk="1" latinLnBrk="0" hangingPunct="1">
-      <a:defRPr sz="1800" kern="1200">
+    <a:lvl9pPr defTabSz="914400" eaLnBrk="1" hangingPunct="1" latinLnBrk="0" lvl="8" marL="3657600" rtl="0" algn="l">
+      <a:defRPr kern="1200" sz="1800">
         <a:solidFill>
           <a:schemeClr val="tx1"/>
         </a:solidFill>
@@ -113,12 +115,11 @@
       </a:defRPr>
     </a:lvl9pPr>
   </p:defaultTextStyle>
-  <p:extLst>
-    <p:ext uri="{EFAFB233-063F-42B5-8137-9DF3F51BA10A}">
-      <p15:sldGuideLst xmlns:p15="http://schemas.microsoft.com/office/powerpoint/2012/main"/>
-    </p:ext>
-  </p:extLst>
 </p:presentation>
+</file>
+
+<file path=ppt/presProps1.xml><?xml version="1.0" encoding="utf-8"?>
+<p:presentationPr xmlns:a="http://schemas.openxmlformats.org/drawingml/2006/main" xmlns:r="http://schemas.openxmlformats.org/officeDocument/2006/relationships" xmlns:mc="http://schemas.openxmlformats.org/markup-compatibility/2006" xmlns:mv="urn:schemas-microsoft-com:mac:vml" xmlns:p="http://schemas.openxmlformats.org/presentationml/2006/main" xmlns:c="http://schemas.openxmlformats.org/drawingml/2006/chart" xmlns:dgm="http://schemas.openxmlformats.org/drawingml/2006/diagram" xmlns:o="urn:schemas-microsoft-com:office:office" xmlns:v="urn:schemas-microsoft-com:vml" xmlns:pvml="urn:schemas-microsoft-com:office:powerpoint" xmlns:com="http://schemas.openxmlformats.org/drawingml/2006/compatibility" xmlns:p14="http://schemas.microsoft.com/office/powerpoint/2010/main" xmlns:p15="http://schemas.microsoft.com/office/powerpoint/2012/main" xmlns:ahyp="http://schemas.microsoft.com/office/drawing/2018/hyperlinkcolor"/>
 </file>
 
 <file path=ppt/notesMasters/notesMaster1.xml><?xml version="1.0" encoding="utf-8"?>
@@ -393,7 +394,101 @@
           <a:p>
             <a:r>
               <a:rPr lang="en-US" dirty="0"/>
-              <a:t>Close on verification. The measurable claim is that every sentence can be traced to a document and a page, and that the system refuses rather than guesses when the documents do not cover the question. Invite questions.</a:t>
+              <a:t>Close on verification. Every claim in an answer can be traced to a document and a page, and the audit gives a faithfulness score for each answer. When the documents do not cover a question, the system says so instead of guessing. Then invite questions, and offer a live demo on the working app.</a:t>
+            </a:r>
+          </a:p>
+        </p:txBody>
+      </p:sp>
+      <p:sp>
+        <p:nvSpPr>
+          <p:cNvPr id="4" name="Slide Number Placeholder 3"/>
+          <p:cNvSpPr>
+            <a:spLocks noGrp="1"/>
+          </p:cNvSpPr>
+          <p:nvPr>
+            <p:ph type="sldNum" sz="quarter" idx="10"/>
+          </p:nvPr>
+        </p:nvSpPr>
+        <p:spPr/>
+        <p:txBody>
+          <a:bodyPr/>
+          <a:lstStyle/>
+          <a:p>
+            <a:fld id="{F7021451-1387-4CA6-816F-3879F97B5CBC}" type="slidenum">
+              <a:rPr lang="en-US"/>
+              <a:t>10</a:t>
+            </a:fld>
+            <a:endParaRPr lang="en-US" dirty="0"/>
+          </a:p>
+        </p:txBody>
+      </p:sp>
+    </p:spTree>
+    <p:extLst>
+      <p:ext uri="{BB962C8B-B14F-4D97-AF65-F5344CB8AC3E}">
+        <p14:creationId xmlns:p14="http://schemas.microsoft.com/office/powerpoint/2010/main" val="1024086991"/>
+      </p:ext>
+    </p:extLst>
+  </p:cSld>
+  <p:clrMapOvr>
+    <a:masterClrMapping/>
+  </p:clrMapOvr>
+</p:notes>
+</file>
+
+<file path=ppt/notesSlides/notesSlide11.xml><?xml version="1.0" encoding="utf-8"?>
+<p:notes xmlns:a="http://schemas.openxmlformats.org/drawingml/2006/main" xmlns:r="http://schemas.openxmlformats.org/officeDocument/2006/relationships" xmlns:p="http://schemas.openxmlformats.org/presentationml/2006/main">
+  <p:cSld>
+    <p:spTree>
+      <p:nvGrpSpPr>
+        <p:cNvPr id="1" name=""/>
+        <p:cNvGrpSpPr/>
+        <p:nvPr/>
+      </p:nvGrpSpPr>
+      <p:grpSpPr>
+        <a:xfrm>
+          <a:off x="0" y="0"/>
+          <a:ext cx="0" cy="0"/>
+          <a:chOff x="0" y="0"/>
+          <a:chExt cx="0" cy="0"/>
+        </a:xfrm>
+      </p:grpSpPr>
+      <p:sp>
+        <p:nvSpPr>
+          <p:cNvPr id="2" name="Slide Image Placeholder 1"/>
+          <p:cNvSpPr>
+            <a:spLocks noGrp="1" noRot="1" noChangeAspect="1"/>
+          </p:cNvSpPr>
+          <p:nvPr>
+            <p:ph type="sldImg"/>
+          </p:nvPr>
+        </p:nvSpPr>
+        <p:spPr/>
+        <p:txBody>
+          <a:bodyPr/>
+          <a:lstStyle/>
+          <a:p>
+            <a:endParaRPr lang="en-US" dirty="0"/>
+          </a:p>
+        </p:txBody>
+      </p:sp>
+      <p:sp>
+        <p:nvSpPr>
+          <p:cNvPr id="3" name="Notes Placeholder 2"/>
+          <p:cNvSpPr>
+            <a:spLocks noGrp="1"/>
+          </p:cNvSpPr>
+          <p:nvPr>
+            <p:ph type="body" idx="1"/>
+          </p:nvPr>
+        </p:nvSpPr>
+        <p:spPr/>
+        <p:txBody>
+          <a:bodyPr/>
+          <a:lstStyle/>
+          <a:p>
+            <a:r>
+              <a:rPr lang="en-US" dirty="0"/>
+              <a:t>All of these reuse the same retrieval pipeline, so every output still points back to a page. The audit is the one to demonstrate: ask a question, run the audit, and the app marks each claim as supported, partial or unsupported, with the quote it relied on. The jury shows whether two different models reach the same answer from the same evidence. Insights and contradiction checks run in a background worker after each upload, so they never slow down a question.</a:t>
             </a:r>
           </a:p>
         </p:txBody>
@@ -581,7 +676,7 @@
           <a:p>
             <a:r>
               <a:rPr lang="en-US" dirty="0"/>
-              <a:t>The five points are the contract the system keeps. Emphasise the last one — citations are what separate this from a chatbot. The refusal card is worth a sentence: a system that cannot say 'I don't know' will always hallucinate when pushed.</a:t>
+              <a:t>These five points are the promise the system keeps on every question. Spend a moment on the last one, because citations are what make this different from an ordinary chatbot. On the refusal card: when nothing relevant is retrieved, the app either says the documents do not cover the question or answers from general knowledge under a clear warning line, so the user always knows which kind of answer they are reading.</a:t>
             </a:r>
           </a:p>
         </p:txBody>
@@ -769,7 +864,7 @@
           <a:p>
             <a:r>
               <a:rPr lang="en-US" dirty="0"/>
-              <a:t>Walk the top row left to right, then the bottom row. The amber connector is the point of the slide: the first pipeline runs once when documents are added, the second runs on every question, and the vector database is the bridge between them.</a:t>
+              <a:t>Go through the top row from left to right, then the bottom row. The amber connector carries the main idea: indexing happens once, when a document is uploaded, while the second pipeline runs on every question. The stored index links the two. With Qwen 2.5 7B on our laptop, a full answer takes around eight seconds, and a repeated question is served from a semantic cache almost instantly.</a:t>
             </a:r>
           </a:p>
         </p:txBody>
@@ -863,7 +958,7 @@
           <a:p>
             <a:r>
               <a:rPr lang="en-US" dirty="0"/>
-              <a:t>Step 4 is the one examiners ask about: the citation is only possible because the page number and document name are stored alongside the vector. If you store just the text, you can retrieve it but you can never say where it came from.</a:t>
+              <a:t>Step 4 usually draws questions. A citation is only possible because the document name and page number are stored with every vector. If only the text were stored, we could still find it, but we could never say where it came from. The index is written to disk, so uploaded documents are still there after the server restarts.</a:t>
             </a:r>
           </a:p>
         </p:txBody>
@@ -957,7 +1052,7 @@
           <a:p>
             <a:r>
               <a:rPr lang="en-US" dirty="0"/>
-              <a:t>Use the example on the right to make step 3 concrete: the three passages come from three different files, which is exactly the case a single-document search tool cannot handle. Mention that the system deliberately caps how many passages come from any one document, so one long file cannot crowd out the others.</a:t>
+              <a:t>The example on the right comes from the demo documents shipped with the app. The three passages come from three different files, which a single-document search tool cannot handle. Keyword search matters here because exact terms such as fee amounts and percentages are easy for embeddings to miss. Reciprocal Rank Fusion merges the two ranked lists, and the MiniLM cross-encoder then rereads each candidate against the question. Anything that scores below a minimum relevance is dropped, so a weak match never turns into a misleading citation.</a:t>
             </a:r>
           </a:p>
         </p:txBody>
@@ -1145,7 +1240,7 @@
           <a:p>
             <a:r>
               <a:rPr lang="en-US" dirty="0"/>
-              <a:t>Two choices worth defending. First, running locally through Ollama means no API cost and no data leaving the machine, which matters for policy or student records. Second, retrieval is hybrid — pure vector search misses exact strings like scheme codes and section numbers, which is precisely what people search for.</a:t>
+              <a:t>Two choices are worth defending. First, everything runs locally through Ollama, so there is no API cost and no data leaves the machine, which matters for policy documents and student records. We tried a 14B model first, but answers took over 35 seconds; Qwen 2.5 7B brought that down to about 8. Second, we chose our own NumPy store over ChromaDB or Pinecone. At this scale it is fast, it needs no extra service, and it lets us keep a BM25 index beside the vectors. The Telegram bot is optional and is the only part that needs the internet.</a:t>
             </a:r>
           </a:p>
         </p:txBody>
@@ -1946,7 +2041,7 @@
                 <a:ea typeface="Calibri" pitchFamily="34" charset="-122"/>
                 <a:cs typeface="Calibri" pitchFamily="34" charset="-120"/>
               </a:rPr>
-              <a:t>EXPECTED OUTCOME</a:t>
+              <a:t>OUTCOME</a:t>
             </a:r>
             <a:endParaRPr lang="en-US" sz="1150" dirty="0"/>
           </a:p>
@@ -1985,7 +2080,7 @@
                 <a:ea typeface="Cambria" pitchFamily="34" charset="-122"/>
                 <a:cs typeface="Cambria" pitchFamily="34" charset="-120"/>
               </a:rPr>
-              <a:t>What the system will deliver</a:t>
+              <a:t>What the system delivers</a:t>
             </a:r>
             <a:endParaRPr lang="en-US" sz="3400" dirty="0"/>
           </a:p>
@@ -2855,7 +2950,7 @@
                 <a:ea typeface="Calibri" pitchFamily="34" charset="-122"/>
                 <a:cs typeface="Calibri" pitchFamily="34" charset="-120"/>
               </a:rPr>
-              <a:t>Any answer can be checked at source</a:t>
+              <a:t>Answers audited claim by claim</a:t>
             </a:r>
             <a:endParaRPr lang="en-US" sz="1050" dirty="0"/>
           </a:p>
@@ -3610,6 +3705,1228 @@
               <a:t>To build a reliable GenAI system that helps users obtain accurate and verifiable information from multiple documents.</a:t>
             </a:r>
             <a:endParaRPr lang="en-US" sz="1750" dirty="0"/>
+          </a:p>
+        </p:txBody>
+      </p:sp>
+    </p:spTree>
+  </p:cSld>
+  <p:clrMapOvr>
+    <a:masterClrMapping/>
+  </p:clrMapOvr>
+</p:sld>
+</file>
+
+<file path=ppt/slides/slide11.xml><?xml version="1.0" encoding="utf-8"?>
+<p:sld xmlns:a="http://schemas.openxmlformats.org/drawingml/2006/main" xmlns:r="http://schemas.openxmlformats.org/officeDocument/2006/relationships" xmlns:p="http://schemas.openxmlformats.org/presentationml/2006/main">
+  <p:cSld name="Slide 6">
+    <p:bg>
+      <p:bgPr>
+        <a:solidFill>
+          <a:srgbClr val="FFFFFF"/>
+        </a:solidFill>
+        <a:effectLst/>
+      </p:bgPr>
+    </p:bg>
+    <p:spTree>
+      <p:nvGrpSpPr>
+        <p:cNvPr id="1" name=""/>
+        <p:cNvGrpSpPr/>
+        <p:nvPr/>
+      </p:nvGrpSpPr>
+      <p:grpSpPr>
+        <a:xfrm>
+          <a:off x="0" y="0"/>
+          <a:ext cx="0" cy="0"/>
+          <a:chOff x="0" y="0"/>
+          <a:chExt cx="0" cy="0"/>
+        </a:xfrm>
+      </p:grpSpPr>
+      <p:sp>
+        <p:nvSpPr>
+          <p:cNvPr id="2" name="Text 0"/>
+          <p:cNvSpPr txBox="1"/>
+          <p:nvPr/>
+        </p:nvSpPr>
+        <p:spPr>
+          <a:xfrm>
+            <a:off x="566928" y="219456"/>
+            <a:ext cx="11057839" cy="237744"/>
+          </a:xfrm>
+          <a:prstGeom prst="rect">
+            <a:avLst/>
+          </a:prstGeom>
+          <a:noFill/>
+          <a:ln/>
+        </p:spPr>
+        <p:txBody>
+          <a:bodyPr wrap="square" lIns="0" tIns="0" rIns="0" bIns="0" rtlCol="0" anchor="ctr"/>
+          <a:lstStyle/>
+          <a:p>
+            <a:pPr marL="0" indent="0">
+              <a:buNone/>
+            </a:pPr>
+            <a:r>
+              <a:rPr lang="en-US" sz="1150" b="1" kern="0" spc="160" dirty="0">
+                <a:solidFill>
+                  <a:srgbClr val="1C7C7C"/>
+                </a:solidFill>
+                <a:latin typeface="Calibri" pitchFamily="34" charset="0"/>
+                <a:ea typeface="Calibri" pitchFamily="34" charset="-122"/>
+                <a:cs typeface="Calibri" pitchFamily="34" charset="-120"/>
+              </a:rPr>
+              <a:t>BEYOND QUESTION ANSWERING</a:t>
+            </a:r>
+            <a:endParaRPr lang="en-US" sz="1150" dirty="0"/>
+          </a:p>
+        </p:txBody>
+      </p:sp>
+      <p:sp>
+        <p:nvSpPr>
+          <p:cNvPr id="3" name="Text 1"/>
+          <p:cNvSpPr txBox="1"/>
+          <p:nvPr/>
+        </p:nvSpPr>
+        <p:spPr>
+          <a:xfrm>
+            <a:off x="566928" y="384048"/>
+            <a:ext cx="11057839" cy="658368"/>
+          </a:xfrm>
+          <a:prstGeom prst="rect">
+            <a:avLst/>
+          </a:prstGeom>
+          <a:noFill/>
+          <a:ln/>
+        </p:spPr>
+        <p:txBody>
+          <a:bodyPr wrap="square" lIns="0" tIns="0" rIns="0" bIns="0" rtlCol="0" anchor="ctr"/>
+          <a:lstStyle/>
+          <a:p>
+            <a:pPr marL="0" indent="0">
+              <a:buNone/>
+            </a:pPr>
+            <a:r>
+              <a:rPr lang="en-US" sz="3400" b="1" dirty="0">
+                <a:solidFill>
+                  <a:srgbClr val="172B2B"/>
+                </a:solidFill>
+                <a:latin typeface="Cambria" pitchFamily="34" charset="0"/>
+                <a:ea typeface="Cambria" pitchFamily="34" charset="-122"/>
+                <a:cs typeface="Cambria" pitchFamily="34" charset="-120"/>
+              </a:rPr>
+              <a:t>Features built on top of the pipeline</a:t>
+            </a:r>
+            <a:endParaRPr lang="en-US" sz="3400" dirty="0"/>
+          </a:p>
+        </p:txBody>
+      </p:sp>
+      <p:sp>
+        <p:nvSpPr>
+          <p:cNvPr id="4" name="Shape 2"/>
+          <p:cNvSpPr/>
+          <p:nvPr/>
+        </p:nvSpPr>
+        <p:spPr>
+          <a:xfrm>
+            <a:off x="566928" y="1371600"/>
+            <a:ext cx="5373472" cy="1737360"/>
+          </a:xfrm>
+          <a:prstGeom prst="roundRect">
+            <a:avLst>
+              <a:gd name="adj" fmla="val 5263"/>
+            </a:avLst>
+          </a:prstGeom>
+          <a:solidFill>
+            <a:srgbClr val="EFF4F3"/>
+          </a:solidFill>
+          <a:ln w="12700">
+            <a:solidFill>
+              <a:srgbClr val="EFF4F3"/>
+            </a:solidFill>
+            <a:prstDash val="solid"/>
+          </a:ln>
+        </p:spPr>
+        <p:txBody>
+          <a:bodyPr/>
+          <a:lstStyle/>
+          <a:p>
+            <a:endParaRPr dirty="0"/>
+          </a:p>
+        </p:txBody>
+      </p:sp>
+      <p:sp>
+        <p:nvSpPr>
+          <p:cNvPr id="5" name="Shape 3"/>
+          <p:cNvSpPr/>
+          <p:nvPr/>
+        </p:nvSpPr>
+        <p:spPr>
+          <a:xfrm>
+            <a:off x="859536" y="1664208"/>
+            <a:ext cx="493776" cy="493776"/>
+          </a:xfrm>
+          <a:prstGeom prst="ellipse">
+            <a:avLst/>
+          </a:prstGeom>
+          <a:solidFill>
+            <a:srgbClr val="FFFFFF"/>
+          </a:solidFill>
+          <a:ln w="12700">
+            <a:solidFill>
+              <a:srgbClr val="FFFFFF"/>
+            </a:solidFill>
+            <a:prstDash val="solid"/>
+          </a:ln>
+        </p:spPr>
+        <p:txBody>
+          <a:bodyPr/>
+          <a:lstStyle/>
+          <a:p>
+            <a:endParaRPr dirty="0"/>
+          </a:p>
+        </p:txBody>
+      </p:sp>
+      <p:pic>
+        <p:nvPicPr>
+          <p:cNvPr id="6" name="Image 0" descr="preencoded.png"/>
+          <p:cNvPicPr>
+            <a:picLocks noChangeAspect="1"/>
+          </p:cNvPicPr>
+          <p:nvPr/>
+        </p:nvPicPr>
+        <p:blipFill>
+          <a:blip r:embed="rId3"/>
+          <a:stretch>
+            <a:fillRect/>
+          </a:stretch>
+        </p:blipFill>
+        <p:spPr>
+          <a:xfrm>
+            <a:off x="987918" y="1792590"/>
+            <a:ext cx="237012" cy="237012"/>
+          </a:xfrm>
+          <a:prstGeom prst="rect">
+            <a:avLst/>
+          </a:prstGeom>
+        </p:spPr>
+      </p:pic>
+      <p:sp>
+        <p:nvSpPr>
+          <p:cNvPr id="7" name="Shape 4"/>
+          <p:cNvSpPr/>
+          <p:nvPr/>
+        </p:nvSpPr>
+        <p:spPr>
+          <a:xfrm>
+            <a:off x="5336896" y="1664208"/>
+            <a:ext cx="347472" cy="347472"/>
+          </a:xfrm>
+          <a:prstGeom prst="ellipse">
+            <a:avLst/>
+          </a:prstGeom>
+          <a:solidFill>
+            <a:srgbClr val="FFFFFF"/>
+          </a:solidFill>
+          <a:ln w="12700">
+            <a:solidFill>
+              <a:srgbClr val="FFFFFF"/>
+            </a:solidFill>
+            <a:prstDash val="solid"/>
+          </a:ln>
+        </p:spPr>
+        <p:txBody>
+          <a:bodyPr/>
+          <a:lstStyle/>
+          <a:p>
+            <a:endParaRPr dirty="0"/>
+          </a:p>
+        </p:txBody>
+      </p:sp>
+      <p:sp>
+        <p:nvSpPr>
+          <p:cNvPr id="8" name="Text 5"/>
+          <p:cNvSpPr txBox="1"/>
+          <p:nvPr/>
+        </p:nvSpPr>
+        <p:spPr>
+          <a:xfrm>
+            <a:off x="5336896" y="1664208"/>
+            <a:ext cx="347472" cy="347472"/>
+          </a:xfrm>
+          <a:prstGeom prst="rect">
+            <a:avLst/>
+          </a:prstGeom>
+          <a:noFill/>
+          <a:ln/>
+        </p:spPr>
+        <p:txBody>
+          <a:bodyPr wrap="square" lIns="0" tIns="0" rIns="0" bIns="0" rtlCol="0" anchor="ctr"/>
+          <a:lstStyle/>
+          <a:p>
+            <a:pPr marL="0" indent="0" algn="ctr">
+              <a:buNone/>
+            </a:pPr>
+            <a:r>
+              <a:rPr lang="en-US" sz="1100" b="1" dirty="0">
+                <a:solidFill>
+                  <a:srgbClr val="1C7C7C"/>
+                </a:solidFill>
+                <a:latin typeface="Calibri" pitchFamily="34" charset="0"/>
+                <a:ea typeface="Calibri" pitchFamily="34" charset="-122"/>
+                <a:cs typeface="Calibri" pitchFamily="34" charset="-120"/>
+              </a:rPr>
+              <a:t>1</a:t>
+            </a:r>
+            <a:endParaRPr lang="en-US" sz="1100" dirty="0"/>
+          </a:p>
+        </p:txBody>
+      </p:sp>
+      <p:sp>
+        <p:nvSpPr>
+          <p:cNvPr id="9" name="Text 6"/>
+          <p:cNvSpPr txBox="1"/>
+          <p:nvPr/>
+        </p:nvSpPr>
+        <p:spPr>
+          <a:xfrm>
+            <a:off x="1499616" y="1700784"/>
+            <a:ext cx="3764128" cy="347472"/>
+          </a:xfrm>
+          <a:prstGeom prst="rect">
+            <a:avLst/>
+          </a:prstGeom>
+          <a:noFill/>
+          <a:ln/>
+        </p:spPr>
+        <p:txBody>
+          <a:bodyPr wrap="square" lIns="0" tIns="0" rIns="0" bIns="0" rtlCol="0" anchor="ctr"/>
+          <a:lstStyle/>
+          <a:p>
+            <a:pPr marL="0" indent="0">
+              <a:buNone/>
+            </a:pPr>
+            <a:r>
+              <a:rPr lang="en-US" sz="1500" b="1" dirty="0">
+                <a:solidFill>
+                  <a:srgbClr val="172B2B"/>
+                </a:solidFill>
+                <a:latin typeface="Calibri" pitchFamily="34" charset="0"/>
+                <a:ea typeface="Calibri" pitchFamily="34" charset="-122"/>
+                <a:cs typeface="Calibri" pitchFamily="34" charset="-120"/>
+              </a:rPr>
+              <a:t>Answer Audit</a:t>
+            </a:r>
+            <a:endParaRPr lang="en-US" sz="1500" dirty="0"/>
+          </a:p>
+        </p:txBody>
+      </p:sp>
+      <p:sp>
+        <p:nvSpPr>
+          <p:cNvPr id="10" name="Text 7"/>
+          <p:cNvSpPr txBox="1"/>
+          <p:nvPr/>
+        </p:nvSpPr>
+        <p:spPr>
+          <a:xfrm>
+            <a:off x="859536" y="2267712"/>
+            <a:ext cx="4788256" cy="731520"/>
+          </a:xfrm>
+          <a:prstGeom prst="rect">
+            <a:avLst/>
+          </a:prstGeom>
+          <a:noFill/>
+          <a:ln/>
+        </p:spPr>
+        <p:txBody>
+          <a:bodyPr wrap="square" lIns="0" tIns="0" rIns="0" bIns="0" rtlCol="0" anchor="t"/>
+          <a:lstStyle/>
+          <a:p>
+            <a:pPr marL="0" indent="0">
+              <a:lnSpc>
+                <a:spcPts val="1500"/>
+              </a:lnSpc>
+              <a:buNone/>
+            </a:pPr>
+            <a:r>
+              <a:rPr lang="en-US" sz="1150" dirty="0">
+                <a:solidFill>
+                  <a:srgbClr val="5F7271"/>
+                </a:solidFill>
+                <a:latin typeface="Calibri" pitchFamily="34" charset="0"/>
+                <a:ea typeface="Calibri" pitchFamily="34" charset="-122"/>
+                <a:cs typeface="Calibri" pitchFamily="34" charset="-120"/>
+              </a:rPr>
+              <a:t>Each answer is split into claims and checked against its sources. It gets a faithfulness score, and unsupported claims are removed.</a:t>
+            </a:r>
+            <a:endParaRPr lang="en-US" sz="1150" dirty="0"/>
+          </a:p>
+        </p:txBody>
+      </p:sp>
+      <p:sp>
+        <p:nvSpPr>
+          <p:cNvPr id="11" name="Shape 8"/>
+          <p:cNvSpPr/>
+          <p:nvPr/>
+        </p:nvSpPr>
+        <p:spPr>
+          <a:xfrm>
+            <a:off x="6251296" y="1371600"/>
+            <a:ext cx="5373472" cy="1737360"/>
+          </a:xfrm>
+          <a:prstGeom prst="roundRect">
+            <a:avLst>
+              <a:gd name="adj" fmla="val 5263"/>
+            </a:avLst>
+          </a:prstGeom>
+          <a:solidFill>
+            <a:srgbClr val="EFF4F3"/>
+          </a:solidFill>
+          <a:ln w="12700">
+            <a:solidFill>
+              <a:srgbClr val="EFF4F3"/>
+            </a:solidFill>
+            <a:prstDash val="solid"/>
+          </a:ln>
+        </p:spPr>
+        <p:txBody>
+          <a:bodyPr/>
+          <a:lstStyle/>
+          <a:p>
+            <a:endParaRPr dirty="0"/>
+          </a:p>
+        </p:txBody>
+      </p:sp>
+      <p:sp>
+        <p:nvSpPr>
+          <p:cNvPr id="12" name="Shape 9"/>
+          <p:cNvSpPr/>
+          <p:nvPr/>
+        </p:nvSpPr>
+        <p:spPr>
+          <a:xfrm>
+            <a:off x="6543904" y="1664208"/>
+            <a:ext cx="493776" cy="493776"/>
+          </a:xfrm>
+          <a:prstGeom prst="ellipse">
+            <a:avLst/>
+          </a:prstGeom>
+          <a:solidFill>
+            <a:srgbClr val="FFFFFF"/>
+          </a:solidFill>
+          <a:ln w="12700">
+            <a:solidFill>
+              <a:srgbClr val="FFFFFF"/>
+            </a:solidFill>
+            <a:prstDash val="solid"/>
+          </a:ln>
+        </p:spPr>
+        <p:txBody>
+          <a:bodyPr/>
+          <a:lstStyle/>
+          <a:p>
+            <a:endParaRPr dirty="0"/>
+          </a:p>
+        </p:txBody>
+      </p:sp>
+      <p:pic>
+        <p:nvPicPr>
+          <p:cNvPr id="13" name="Image 1" descr="preencoded.png"/>
+          <p:cNvPicPr>
+            <a:picLocks noChangeAspect="1"/>
+          </p:cNvPicPr>
+          <p:nvPr/>
+        </p:nvPicPr>
+        <p:blipFill>
+          <a:blip r:embed="rId4"/>
+          <a:stretch>
+            <a:fillRect/>
+          </a:stretch>
+        </p:blipFill>
+        <p:spPr>
+          <a:xfrm>
+            <a:off x="6672285" y="1792590"/>
+            <a:ext cx="237012" cy="237012"/>
+          </a:xfrm>
+          <a:prstGeom prst="rect">
+            <a:avLst/>
+          </a:prstGeom>
+        </p:spPr>
+      </p:pic>
+      <p:sp>
+        <p:nvSpPr>
+          <p:cNvPr id="14" name="Shape 10"/>
+          <p:cNvSpPr/>
+          <p:nvPr/>
+        </p:nvSpPr>
+        <p:spPr>
+          <a:xfrm>
+            <a:off x="11021263" y="1664208"/>
+            <a:ext cx="347472" cy="347472"/>
+          </a:xfrm>
+          <a:prstGeom prst="ellipse">
+            <a:avLst/>
+          </a:prstGeom>
+          <a:solidFill>
+            <a:srgbClr val="FFFFFF"/>
+          </a:solidFill>
+          <a:ln w="12700">
+            <a:solidFill>
+              <a:srgbClr val="FFFFFF"/>
+            </a:solidFill>
+            <a:prstDash val="solid"/>
+          </a:ln>
+        </p:spPr>
+        <p:txBody>
+          <a:bodyPr/>
+          <a:lstStyle/>
+          <a:p>
+            <a:endParaRPr dirty="0"/>
+          </a:p>
+        </p:txBody>
+      </p:sp>
+      <p:sp>
+        <p:nvSpPr>
+          <p:cNvPr id="15" name="Text 11"/>
+          <p:cNvSpPr txBox="1"/>
+          <p:nvPr/>
+        </p:nvSpPr>
+        <p:spPr>
+          <a:xfrm>
+            <a:off x="11021263" y="1664208"/>
+            <a:ext cx="347472" cy="347472"/>
+          </a:xfrm>
+          <a:prstGeom prst="rect">
+            <a:avLst/>
+          </a:prstGeom>
+          <a:noFill/>
+          <a:ln/>
+        </p:spPr>
+        <p:txBody>
+          <a:bodyPr wrap="square" lIns="0" tIns="0" rIns="0" bIns="0" rtlCol="0" anchor="ctr"/>
+          <a:lstStyle/>
+          <a:p>
+            <a:pPr marL="0" indent="0" algn="ctr">
+              <a:buNone/>
+            </a:pPr>
+            <a:r>
+              <a:rPr lang="en-US" sz="1100" b="1" dirty="0">
+                <a:solidFill>
+                  <a:srgbClr val="1C7C7C"/>
+                </a:solidFill>
+                <a:latin typeface="Calibri" pitchFamily="34" charset="0"/>
+                <a:ea typeface="Calibri" pitchFamily="34" charset="-122"/>
+                <a:cs typeface="Calibri" pitchFamily="34" charset="-120"/>
+              </a:rPr>
+              <a:t>2</a:t>
+            </a:r>
+            <a:endParaRPr lang="en-US" sz="1100" dirty="0"/>
+          </a:p>
+        </p:txBody>
+      </p:sp>
+      <p:sp>
+        <p:nvSpPr>
+          <p:cNvPr id="16" name="Text 12"/>
+          <p:cNvSpPr txBox="1"/>
+          <p:nvPr/>
+        </p:nvSpPr>
+        <p:spPr>
+          <a:xfrm>
+            <a:off x="7183984" y="1700784"/>
+            <a:ext cx="3764128" cy="347472"/>
+          </a:xfrm>
+          <a:prstGeom prst="rect">
+            <a:avLst/>
+          </a:prstGeom>
+          <a:noFill/>
+          <a:ln/>
+        </p:spPr>
+        <p:txBody>
+          <a:bodyPr wrap="square" lIns="0" tIns="0" rIns="0" bIns="0" rtlCol="0" anchor="ctr"/>
+          <a:lstStyle/>
+          <a:p>
+            <a:pPr marL="0" indent="0">
+              <a:buNone/>
+            </a:pPr>
+            <a:r>
+              <a:rPr lang="en-US" sz="1500" b="1" dirty="0">
+                <a:solidFill>
+                  <a:srgbClr val="172B2B"/>
+                </a:solidFill>
+                <a:latin typeface="Calibri" pitchFamily="34" charset="0"/>
+                <a:ea typeface="Calibri" pitchFamily="34" charset="-122"/>
+                <a:cs typeface="Calibri" pitchFamily="34" charset="-120"/>
+              </a:rPr>
+              <a:t>Model Jury</a:t>
+            </a:r>
+            <a:endParaRPr lang="en-US" sz="1500" dirty="0"/>
+          </a:p>
+        </p:txBody>
+      </p:sp>
+      <p:sp>
+        <p:nvSpPr>
+          <p:cNvPr id="17" name="Text 13"/>
+          <p:cNvSpPr txBox="1"/>
+          <p:nvPr/>
+        </p:nvSpPr>
+        <p:spPr>
+          <a:xfrm>
+            <a:off x="6543904" y="2267712"/>
+            <a:ext cx="4788256" cy="731520"/>
+          </a:xfrm>
+          <a:prstGeom prst="rect">
+            <a:avLst/>
+          </a:prstGeom>
+          <a:noFill/>
+          <a:ln/>
+        </p:spPr>
+        <p:txBody>
+          <a:bodyPr wrap="square" lIns="0" tIns="0" rIns="0" bIns="0" rtlCol="0" anchor="t"/>
+          <a:lstStyle/>
+          <a:p>
+            <a:pPr marL="0" indent="0">
+              <a:lnSpc>
+                <a:spcPts val="1500"/>
+              </a:lnSpc>
+              <a:buNone/>
+            </a:pPr>
+            <a:r>
+              <a:rPr lang="en-US" sz="1150" dirty="0">
+                <a:solidFill>
+                  <a:srgbClr val="5F7271"/>
+                </a:solidFill>
+                <a:latin typeface="Calibri" pitchFamily="34" charset="0"/>
+                <a:ea typeface="Calibri" pitchFamily="34" charset="-122"/>
+                <a:cs typeface="Calibri" pitchFamily="34" charset="-120"/>
+              </a:rPr>
+              <a:t>Qwen 2.5 7B and Llama 3.1 8B answer from the same passages, and a judge model reports where the two agree or differ.</a:t>
+            </a:r>
+            <a:endParaRPr lang="en-US" sz="1150" dirty="0"/>
+          </a:p>
+        </p:txBody>
+      </p:sp>
+      <p:sp>
+        <p:nvSpPr>
+          <p:cNvPr id="18" name="Shape 14"/>
+          <p:cNvSpPr/>
+          <p:nvPr/>
+        </p:nvSpPr>
+        <p:spPr>
+          <a:xfrm>
+            <a:off x="566928" y="3419856"/>
+            <a:ext cx="5373472" cy="1737360"/>
+          </a:xfrm>
+          <a:prstGeom prst="roundRect">
+            <a:avLst>
+              <a:gd name="adj" fmla="val 5263"/>
+            </a:avLst>
+          </a:prstGeom>
+          <a:solidFill>
+            <a:srgbClr val="EFF4F3"/>
+          </a:solidFill>
+          <a:ln w="12700">
+            <a:solidFill>
+              <a:srgbClr val="EFF4F3"/>
+            </a:solidFill>
+            <a:prstDash val="solid"/>
+          </a:ln>
+        </p:spPr>
+        <p:txBody>
+          <a:bodyPr/>
+          <a:lstStyle/>
+          <a:p>
+            <a:endParaRPr dirty="0"/>
+          </a:p>
+        </p:txBody>
+      </p:sp>
+      <p:sp>
+        <p:nvSpPr>
+          <p:cNvPr id="19" name="Shape 15"/>
+          <p:cNvSpPr/>
+          <p:nvPr/>
+        </p:nvSpPr>
+        <p:spPr>
+          <a:xfrm>
+            <a:off x="859536" y="3712464"/>
+            <a:ext cx="493776" cy="493776"/>
+          </a:xfrm>
+          <a:prstGeom prst="ellipse">
+            <a:avLst/>
+          </a:prstGeom>
+          <a:solidFill>
+            <a:srgbClr val="FFFFFF"/>
+          </a:solidFill>
+          <a:ln w="12700">
+            <a:solidFill>
+              <a:srgbClr val="FFFFFF"/>
+            </a:solidFill>
+            <a:prstDash val="solid"/>
+          </a:ln>
+        </p:spPr>
+        <p:txBody>
+          <a:bodyPr/>
+          <a:lstStyle/>
+          <a:p>
+            <a:endParaRPr dirty="0"/>
+          </a:p>
+        </p:txBody>
+      </p:sp>
+      <p:pic>
+        <p:nvPicPr>
+          <p:cNvPr id="20" name="Image 2" descr="preencoded.png"/>
+          <p:cNvPicPr>
+            <a:picLocks noChangeAspect="1"/>
+          </p:cNvPicPr>
+          <p:nvPr/>
+        </p:nvPicPr>
+        <p:blipFill>
+          <a:blip r:embed="rId5"/>
+          <a:stretch>
+            <a:fillRect/>
+          </a:stretch>
+        </p:blipFill>
+        <p:spPr>
+          <a:xfrm>
+            <a:off x="987918" y="3840846"/>
+            <a:ext cx="237012" cy="237012"/>
+          </a:xfrm>
+          <a:prstGeom prst="rect">
+            <a:avLst/>
+          </a:prstGeom>
+        </p:spPr>
+      </p:pic>
+      <p:sp>
+        <p:nvSpPr>
+          <p:cNvPr id="21" name="Shape 16"/>
+          <p:cNvSpPr/>
+          <p:nvPr/>
+        </p:nvSpPr>
+        <p:spPr>
+          <a:xfrm>
+            <a:off x="5336896" y="3712464"/>
+            <a:ext cx="347472" cy="347472"/>
+          </a:xfrm>
+          <a:prstGeom prst="ellipse">
+            <a:avLst/>
+          </a:prstGeom>
+          <a:solidFill>
+            <a:srgbClr val="FFFFFF"/>
+          </a:solidFill>
+          <a:ln w="12700">
+            <a:solidFill>
+              <a:srgbClr val="FFFFFF"/>
+            </a:solidFill>
+            <a:prstDash val="solid"/>
+          </a:ln>
+        </p:spPr>
+        <p:txBody>
+          <a:bodyPr/>
+          <a:lstStyle/>
+          <a:p>
+            <a:endParaRPr dirty="0"/>
+          </a:p>
+        </p:txBody>
+      </p:sp>
+      <p:sp>
+        <p:nvSpPr>
+          <p:cNvPr id="22" name="Text 17"/>
+          <p:cNvSpPr txBox="1"/>
+          <p:nvPr/>
+        </p:nvSpPr>
+        <p:spPr>
+          <a:xfrm>
+            <a:off x="5336896" y="3712464"/>
+            <a:ext cx="347472" cy="347472"/>
+          </a:xfrm>
+          <a:prstGeom prst="rect">
+            <a:avLst/>
+          </a:prstGeom>
+          <a:noFill/>
+          <a:ln/>
+        </p:spPr>
+        <p:txBody>
+          <a:bodyPr wrap="square" lIns="0" tIns="0" rIns="0" bIns="0" rtlCol="0" anchor="ctr"/>
+          <a:lstStyle/>
+          <a:p>
+            <a:pPr marL="0" indent="0" algn="ctr">
+              <a:buNone/>
+            </a:pPr>
+            <a:r>
+              <a:rPr lang="en-US" sz="1100" b="1" dirty="0">
+                <a:solidFill>
+                  <a:srgbClr val="1C7C7C"/>
+                </a:solidFill>
+                <a:latin typeface="Calibri" pitchFamily="34" charset="0"/>
+                <a:ea typeface="Calibri" pitchFamily="34" charset="-122"/>
+                <a:cs typeface="Calibri" pitchFamily="34" charset="-120"/>
+              </a:rPr>
+              <a:t>3</a:t>
+            </a:r>
+            <a:endParaRPr lang="en-US" sz="1100" dirty="0"/>
+          </a:p>
+        </p:txBody>
+      </p:sp>
+      <p:sp>
+        <p:nvSpPr>
+          <p:cNvPr id="23" name="Text 18"/>
+          <p:cNvSpPr txBox="1"/>
+          <p:nvPr/>
+        </p:nvSpPr>
+        <p:spPr>
+          <a:xfrm>
+            <a:off x="1499616" y="3749040"/>
+            <a:ext cx="3764128" cy="347472"/>
+          </a:xfrm>
+          <a:prstGeom prst="rect">
+            <a:avLst/>
+          </a:prstGeom>
+          <a:noFill/>
+          <a:ln/>
+        </p:spPr>
+        <p:txBody>
+          <a:bodyPr wrap="square" lIns="0" tIns="0" rIns="0" bIns="0" rtlCol="0" anchor="ctr"/>
+          <a:lstStyle/>
+          <a:p>
+            <a:pPr marL="0" indent="0">
+              <a:buNone/>
+            </a:pPr>
+            <a:r>
+              <a:rPr lang="en-US" sz="1500" b="1" dirty="0">
+                <a:solidFill>
+                  <a:srgbClr val="172B2B"/>
+                </a:solidFill>
+                <a:latin typeface="Calibri" pitchFamily="34" charset="0"/>
+                <a:ea typeface="Calibri" pitchFamily="34" charset="-122"/>
+                <a:cs typeface="Calibri" pitchFamily="34" charset="-120"/>
+              </a:rPr>
+              <a:t>Document Insights</a:t>
+            </a:r>
+            <a:endParaRPr lang="en-US" sz="1500" dirty="0"/>
+          </a:p>
+        </p:txBody>
+      </p:sp>
+      <p:sp>
+        <p:nvSpPr>
+          <p:cNvPr id="24" name="Text 19"/>
+          <p:cNvSpPr txBox="1"/>
+          <p:nvPr/>
+        </p:nvSpPr>
+        <p:spPr>
+          <a:xfrm>
+            <a:off x="859536" y="4315968"/>
+            <a:ext cx="4788256" cy="731520"/>
+          </a:xfrm>
+          <a:prstGeom prst="rect">
+            <a:avLst/>
+          </a:prstGeom>
+          <a:noFill/>
+          <a:ln/>
+        </p:spPr>
+        <p:txBody>
+          <a:bodyPr wrap="square" lIns="0" tIns="0" rIns="0" bIns="0" rtlCol="0" anchor="t"/>
+          <a:lstStyle/>
+          <a:p>
+            <a:pPr marL="0" indent="0">
+              <a:lnSpc>
+                <a:spcPts val="1500"/>
+              </a:lnSpc>
+              <a:buNone/>
+            </a:pPr>
+            <a:r>
+              <a:rPr lang="en-US" sz="1150" dirty="0">
+                <a:solidFill>
+                  <a:srgbClr val="5F7271"/>
+                </a:solidFill>
+                <a:latin typeface="Calibri" pitchFamily="34" charset="0"/>
+                <a:ea typeface="Calibri" pitchFamily="34" charset="-122"/>
+                <a:cs typeface="Calibri" pitchFamily="34" charset="-120"/>
+              </a:rPr>
+              <a:t>After upload, each file gets a summary, FAQ, quiz, timeline and knowledge graph, and is checked for clashes with other files.</a:t>
+            </a:r>
+            <a:endParaRPr lang="en-US" sz="1150" dirty="0"/>
+          </a:p>
+        </p:txBody>
+      </p:sp>
+      <p:sp>
+        <p:nvSpPr>
+          <p:cNvPr id="25" name="Shape 20"/>
+          <p:cNvSpPr/>
+          <p:nvPr/>
+        </p:nvSpPr>
+        <p:spPr>
+          <a:xfrm>
+            <a:off x="6251296" y="3419856"/>
+            <a:ext cx="5373472" cy="1737360"/>
+          </a:xfrm>
+          <a:prstGeom prst="roundRect">
+            <a:avLst>
+              <a:gd name="adj" fmla="val 5263"/>
+            </a:avLst>
+          </a:prstGeom>
+          <a:solidFill>
+            <a:srgbClr val="EFF4F3"/>
+          </a:solidFill>
+          <a:ln w="12700">
+            <a:solidFill>
+              <a:srgbClr val="EFF4F3"/>
+            </a:solidFill>
+            <a:prstDash val="solid"/>
+          </a:ln>
+        </p:spPr>
+        <p:txBody>
+          <a:bodyPr/>
+          <a:lstStyle/>
+          <a:p>
+            <a:endParaRPr dirty="0"/>
+          </a:p>
+        </p:txBody>
+      </p:sp>
+      <p:sp>
+        <p:nvSpPr>
+          <p:cNvPr id="26" name="Shape 21"/>
+          <p:cNvSpPr/>
+          <p:nvPr/>
+        </p:nvSpPr>
+        <p:spPr>
+          <a:xfrm>
+            <a:off x="6543904" y="3712464"/>
+            <a:ext cx="493776" cy="493776"/>
+          </a:xfrm>
+          <a:prstGeom prst="ellipse">
+            <a:avLst/>
+          </a:prstGeom>
+          <a:solidFill>
+            <a:srgbClr val="FFFFFF"/>
+          </a:solidFill>
+          <a:ln w="12700">
+            <a:solidFill>
+              <a:srgbClr val="FFFFFF"/>
+            </a:solidFill>
+            <a:prstDash val="solid"/>
+          </a:ln>
+        </p:spPr>
+        <p:txBody>
+          <a:bodyPr/>
+          <a:lstStyle/>
+          <a:p>
+            <a:endParaRPr dirty="0"/>
+          </a:p>
+        </p:txBody>
+      </p:sp>
+      <p:pic>
+        <p:nvPicPr>
+          <p:cNvPr id="27" name="Image 3" descr="preencoded.png"/>
+          <p:cNvPicPr>
+            <a:picLocks noChangeAspect="1"/>
+          </p:cNvPicPr>
+          <p:nvPr/>
+        </p:nvPicPr>
+        <p:blipFill>
+          <a:blip r:embed="rId6"/>
+          <a:stretch>
+            <a:fillRect/>
+          </a:stretch>
+        </p:blipFill>
+        <p:spPr>
+          <a:xfrm>
+            <a:off x="6672285" y="3840846"/>
+            <a:ext cx="237012" cy="237012"/>
+          </a:xfrm>
+          <a:prstGeom prst="rect">
+            <a:avLst/>
+          </a:prstGeom>
+        </p:spPr>
+      </p:pic>
+      <p:sp>
+        <p:nvSpPr>
+          <p:cNvPr id="28" name="Shape 22"/>
+          <p:cNvSpPr/>
+          <p:nvPr/>
+        </p:nvSpPr>
+        <p:spPr>
+          <a:xfrm>
+            <a:off x="11021263" y="3712464"/>
+            <a:ext cx="347472" cy="347472"/>
+          </a:xfrm>
+          <a:prstGeom prst="ellipse">
+            <a:avLst/>
+          </a:prstGeom>
+          <a:solidFill>
+            <a:srgbClr val="FFFFFF"/>
+          </a:solidFill>
+          <a:ln w="12700">
+            <a:solidFill>
+              <a:srgbClr val="FFFFFF"/>
+            </a:solidFill>
+            <a:prstDash val="solid"/>
+          </a:ln>
+        </p:spPr>
+        <p:txBody>
+          <a:bodyPr/>
+          <a:lstStyle/>
+          <a:p>
+            <a:endParaRPr dirty="0"/>
+          </a:p>
+        </p:txBody>
+      </p:sp>
+      <p:sp>
+        <p:nvSpPr>
+          <p:cNvPr id="29" name="Text 23"/>
+          <p:cNvSpPr txBox="1"/>
+          <p:nvPr/>
+        </p:nvSpPr>
+        <p:spPr>
+          <a:xfrm>
+            <a:off x="11021263" y="3712464"/>
+            <a:ext cx="347472" cy="347472"/>
+          </a:xfrm>
+          <a:prstGeom prst="rect">
+            <a:avLst/>
+          </a:prstGeom>
+          <a:noFill/>
+          <a:ln/>
+        </p:spPr>
+        <p:txBody>
+          <a:bodyPr wrap="square" lIns="0" tIns="0" rIns="0" bIns="0" rtlCol="0" anchor="ctr"/>
+          <a:lstStyle/>
+          <a:p>
+            <a:pPr marL="0" indent="0" algn="ctr">
+              <a:buNone/>
+            </a:pPr>
+            <a:r>
+              <a:rPr lang="en-US" sz="1100" b="1" dirty="0">
+                <a:solidFill>
+                  <a:srgbClr val="1C7C7C"/>
+                </a:solidFill>
+                <a:latin typeface="Calibri" pitchFamily="34" charset="0"/>
+                <a:ea typeface="Calibri" pitchFamily="34" charset="-122"/>
+                <a:cs typeface="Calibri" pitchFamily="34" charset="-120"/>
+              </a:rPr>
+              <a:t>4</a:t>
+            </a:r>
+            <a:endParaRPr lang="en-US" sz="1100" dirty="0"/>
+          </a:p>
+        </p:txBody>
+      </p:sp>
+      <p:sp>
+        <p:nvSpPr>
+          <p:cNvPr id="30" name="Text 24"/>
+          <p:cNvSpPr txBox="1"/>
+          <p:nvPr/>
+        </p:nvSpPr>
+        <p:spPr>
+          <a:xfrm>
+            <a:off x="7183984" y="3749040"/>
+            <a:ext cx="3764128" cy="347472"/>
+          </a:xfrm>
+          <a:prstGeom prst="rect">
+            <a:avLst/>
+          </a:prstGeom>
+          <a:noFill/>
+          <a:ln/>
+        </p:spPr>
+        <p:txBody>
+          <a:bodyPr wrap="square" lIns="0" tIns="0" rIns="0" bIns="0" rtlCol="0" anchor="ctr"/>
+          <a:lstStyle/>
+          <a:p>
+            <a:pPr marL="0" indent="0">
+              <a:buNone/>
+            </a:pPr>
+            <a:r>
+              <a:rPr lang="en-US" sz="1500" b="1" dirty="0">
+                <a:solidFill>
+                  <a:srgbClr val="172B2B"/>
+                </a:solidFill>
+                <a:latin typeface="Calibri" pitchFamily="34" charset="0"/>
+                <a:ea typeface="Calibri" pitchFamily="34" charset="-122"/>
+                <a:cs typeface="Calibri" pitchFamily="34" charset="-120"/>
+              </a:rPr>
+              <a:t>Voice and Telegram</a:t>
+            </a:r>
+            <a:endParaRPr lang="en-US" sz="1500" dirty="0"/>
+          </a:p>
+        </p:txBody>
+      </p:sp>
+      <p:sp>
+        <p:nvSpPr>
+          <p:cNvPr id="31" name="Text 25"/>
+          <p:cNvSpPr txBox="1"/>
+          <p:nvPr/>
+        </p:nvSpPr>
+        <p:spPr>
+          <a:xfrm>
+            <a:off x="6543904" y="4315968"/>
+            <a:ext cx="4788256" cy="731520"/>
+          </a:xfrm>
+          <a:prstGeom prst="rect">
+            <a:avLst/>
+          </a:prstGeom>
+          <a:noFill/>
+          <a:ln/>
+        </p:spPr>
+        <p:txBody>
+          <a:bodyPr wrap="square" lIns="0" tIns="0" rIns="0" bIns="0" rtlCol="0" anchor="t"/>
+          <a:lstStyle/>
+          <a:p>
+            <a:pPr marL="0" indent="0">
+              <a:lnSpc>
+                <a:spcPts val="1500"/>
+              </a:lnSpc>
+              <a:buNone/>
+            </a:pPr>
+            <a:r>
+              <a:rPr lang="en-US" sz="1150" dirty="0">
+                <a:solidFill>
+                  <a:srgbClr val="5F7271"/>
+                </a:solidFill>
+                <a:latin typeface="Calibri" pitchFamily="34" charset="0"/>
+                <a:ea typeface="Calibri" pitchFamily="34" charset="-122"/>
+                <a:cs typeface="Calibri" pitchFamily="34" charset="-120"/>
+              </a:rPr>
+              <a:t>Questions can be spoken in English, Hindi or Marathi and transcribed locally by Whisper, or sent through a Telegram bot.</a:t>
+            </a:r>
+            <a:endParaRPr lang="en-US" sz="1150" dirty="0"/>
+          </a:p>
+        </p:txBody>
+      </p:sp>
+      <p:sp>
+        <p:nvSpPr>
+          <p:cNvPr id="32" name="Shape 26"/>
+          <p:cNvSpPr/>
+          <p:nvPr/>
+        </p:nvSpPr>
+        <p:spPr>
+          <a:xfrm>
+            <a:off x="566928" y="5285232"/>
+            <a:ext cx="11057839" cy="1042416"/>
+          </a:xfrm>
+          <a:prstGeom prst="roundRect">
+            <a:avLst>
+              <a:gd name="adj" fmla="val 10526"/>
+            </a:avLst>
+          </a:prstGeom>
+          <a:solidFill>
+            <a:srgbClr val="12545A"/>
+          </a:solidFill>
+          <a:ln w="12700">
+            <a:solidFill>
+              <a:srgbClr val="12545A"/>
+            </a:solidFill>
+            <a:prstDash val="solid"/>
+          </a:ln>
+        </p:spPr>
+        <p:txBody>
+          <a:bodyPr/>
+          <a:lstStyle/>
+          <a:p>
+            <a:endParaRPr dirty="0"/>
+          </a:p>
+        </p:txBody>
+      </p:sp>
+      <p:sp>
+        <p:nvSpPr>
+          <p:cNvPr id="33" name="Shape 27"/>
+          <p:cNvSpPr/>
+          <p:nvPr/>
+        </p:nvSpPr>
+        <p:spPr>
+          <a:xfrm>
+            <a:off x="896112" y="5568696"/>
+            <a:ext cx="475488" cy="475488"/>
+          </a:xfrm>
+          <a:prstGeom prst="ellipse">
+            <a:avLst/>
+          </a:prstGeom>
+          <a:solidFill>
+            <a:srgbClr val="E8A33D"/>
+          </a:solidFill>
+          <a:ln w="12700">
+            <a:solidFill>
+              <a:srgbClr val="E8A33D"/>
+            </a:solidFill>
+            <a:prstDash val="solid"/>
+          </a:ln>
+        </p:spPr>
+        <p:txBody>
+          <a:bodyPr/>
+          <a:lstStyle/>
+          <a:p>
+            <a:endParaRPr dirty="0"/>
+          </a:p>
+        </p:txBody>
+      </p:sp>
+      <p:pic>
+        <p:nvPicPr>
+          <p:cNvPr id="34" name="Image 4" descr="preencoded.png"/>
+          <p:cNvPicPr>
+            <a:picLocks noChangeAspect="1"/>
+          </p:cNvPicPr>
+          <p:nvPr/>
+        </p:nvPicPr>
+        <p:blipFill>
+          <a:blip r:embed="rId7"/>
+          <a:stretch>
+            <a:fillRect/>
+          </a:stretch>
+        </p:blipFill>
+        <p:spPr>
+          <a:xfrm>
+            <a:off x="1019739" y="5692323"/>
+            <a:ext cx="228234" cy="228234"/>
+          </a:xfrm>
+          <a:prstGeom prst="rect">
+            <a:avLst/>
+          </a:prstGeom>
+        </p:spPr>
+      </p:pic>
+      <p:sp>
+        <p:nvSpPr>
+          <p:cNvPr id="35" name="Text 28"/>
+          <p:cNvSpPr txBox="1"/>
+          <p:nvPr/>
+        </p:nvSpPr>
+        <p:spPr>
+          <a:xfrm>
+            <a:off x="1517904" y="5431536"/>
+            <a:ext cx="9741103" cy="749808"/>
+          </a:xfrm>
+          <a:prstGeom prst="rect">
+            <a:avLst/>
+          </a:prstGeom>
+          <a:noFill/>
+          <a:ln/>
+        </p:spPr>
+        <p:txBody>
+          <a:bodyPr wrap="square" lIns="0" tIns="0" rIns="0" bIns="0" rtlCol="0" anchor="ctr"/>
+          <a:lstStyle/>
+          <a:p>
+            <a:pPr marL="0" indent="0">
+              <a:lnSpc>
+                <a:spcPts val="2000"/>
+              </a:lnSpc>
+              <a:buNone/>
+            </a:pPr>
+            <a:r>
+              <a:rPr lang="en-US" sz="1400" b="1" dirty="0">
+                <a:solidFill>
+                  <a:srgbClr val="E8A33D"/>
+                </a:solidFill>
+                <a:latin typeface="Calibri" pitchFamily="34" charset="0"/>
+                <a:ea typeface="Calibri" pitchFamily="34" charset="-122"/>
+                <a:cs typeface="Calibri" pitchFamily="34" charset="-120"/>
+              </a:rPr>
+              <a:t>Self-tuning:  </a:t>
+            </a:r>
+            <a:r>
+              <a:rPr lang="en-US" sz="1400" dirty="0">
+                <a:solidFill>
+                  <a:srgbClr val="FFFFFF"/>
+                </a:solidFill>
+                <a:latin typeface="Calibri" pitchFamily="34" charset="0"/>
+                <a:ea typeface="Calibri" pitchFamily="34" charset="-122"/>
+                <a:cs typeface="Calibri" pitchFamily="34" charset="-120"/>
+              </a:rPr>
+              <a:t>user feedback builds a test set every night, and retrieval settings change only when Hit@k or MRR clearly improves.</a:t>
+            </a:r>
+            <a:endParaRPr lang="en-US" sz="1400" dirty="0"/>
           </a:p>
         </p:txBody>
       </p:sp>
@@ -5301,7 +6618,7 @@
                 <a:ea typeface="Calibri" pitchFamily="34" charset="-122"/>
                 <a:cs typeface="Calibri" pitchFamily="34" charset="-120"/>
               </a:rPr>
-              <a:t>Text extraction, cleaning and page-aware segmentation</a:t>
+              <a:t>PDF, Word and text files, with OCR for scans and photos</a:t>
             </a:r>
             <a:endParaRPr lang="en-US" sz="1150" dirty="0"/>
           </a:p>
@@ -5450,7 +6767,7 @@
                 <a:ea typeface="Calibri" pitchFamily="34" charset="-122"/>
                 <a:cs typeface="Calibri" pitchFamily="34" charset="-120"/>
               </a:rPr>
-              <a:t>Semantic and keyword search over every document at once</a:t>
+              <a:t>Hybrid semantic and keyword search, then reranking</a:t>
             </a:r>
             <a:endParaRPr lang="en-US" sz="1150" dirty="0"/>
           </a:p>
@@ -5748,7 +7065,7 @@
                 <a:ea typeface="Calibri" pitchFamily="34" charset="-122"/>
                 <a:cs typeface="Calibri" pitchFamily="34" charset="-120"/>
               </a:rPr>
-              <a:t>Every sentence carries a marker back to its source</a:t>
+              <a:t>Every claim carries a [Doc, Page] marker to its source</a:t>
             </a:r>
             <a:endParaRPr lang="en-US" sz="1150" dirty="0"/>
           </a:p>
@@ -6095,7 +7412,7 @@
                 <a:ea typeface="Calibri" pitchFamily="34" charset="-122"/>
                 <a:cs typeface="Calibri" pitchFamily="34" charset="-120"/>
               </a:rPr>
-              <a:t>When the documents do not contain the answer, the system says so instead of inventing one.</a:t>
+              <a:t>When the documents do not hold the answer, it says so. A general-knowledge reply is always flagged.</a:t>
             </a:r>
             <a:endParaRPr lang="en-US" sz="1100" dirty="0"/>
           </a:p>
@@ -7329,7 +8646,7 @@
                 <a:ea typeface="Cambria" pitchFamily="34" charset="-122"/>
                 <a:cs typeface="Cambria" pitchFamily="34" charset="-120"/>
               </a:rPr>
-              <a:t>How the system will work</a:t>
+              <a:t>How the system works</a:t>
             </a:r>
             <a:endParaRPr lang="en-US" sz="3400" dirty="0"/>
           </a:p>
@@ -8388,7 +9705,7 @@
                 <a:ea typeface="Calibri" pitchFamily="34" charset="-122"/>
                 <a:cs typeface="Calibri" pitchFamily="34" charset="-120"/>
               </a:rPr>
-              <a:t>Similarity Search</a:t>
+              <a:t>Hybrid Search</a:t>
             </a:r>
             <a:endParaRPr lang="en-US" sz="1200" dirty="0"/>
           </a:p>
@@ -8408,7 +9725,7 @@
                 <a:ea typeface="Calibri" pitchFamily="34" charset="-122"/>
                 <a:cs typeface="Calibri" pitchFamily="34" charset="-120"/>
               </a:rPr>
-              <a:t>&amp; Retrieval</a:t>
+              <a:t>&amp; Reranking</a:t>
             </a:r>
             <a:endParaRPr lang="en-US" sz="1200" dirty="0"/>
           </a:p>
@@ -9240,7 +10557,7 @@
                 <a:ea typeface="Calibri" pitchFamily="34" charset="-122"/>
                 <a:cs typeface="Calibri" pitchFamily="34" charset="-120"/>
               </a:rPr>
-              <a:t>a question is asked, in a couple of seconds</a:t>
+              <a:t>a question is asked, answered in about 8 seconds</a:t>
             </a:r>
             <a:endParaRPr lang="en-US" sz="1000" dirty="0"/>
           </a:p>
@@ -9761,7 +11078,7 @@
                 <a:ea typeface="Calibri" pitchFamily="34" charset="-122"/>
                 <a:cs typeface="Calibri" pitchFamily="34" charset="-120"/>
               </a:rPr>
-              <a:t>Pull usable text out of every uploaded document, including tables. Scanned pages are read with OCR so image-only PDFs are not lost.</a:t>
+              <a:t>pdfplumber reads text and tables page by page. Scanned pages and photos go through Tesseract OCR in English, Hindi and Marathi.</a:t>
             </a:r>
             <a:endParaRPr lang="en-US" sz="1150" dirty="0"/>
           </a:p>
@@ -10003,7 +11320,7 @@
                 <a:ea typeface="Calibri" pitchFamily="34" charset="-122"/>
                 <a:cs typeface="Calibri" pitchFamily="34" charset="-120"/>
               </a:rPr>
-              <a:t>Split long documents into smaller passages at sentence boundaries, each one small enough to be quoted precisely.</a:t>
+              <a:t>Each page is split into passages of about 800 characters with a 150-character overlap, breaking at paragraphs and sentences.</a:t>
             </a:r>
             <a:endParaRPr lang="en-US" sz="1150" dirty="0"/>
           </a:p>
@@ -10245,7 +11562,7 @@
                 <a:ea typeface="Calibri" pitchFamily="34" charset="-122"/>
                 <a:cs typeface="Calibri" pitchFamily="34" charset="-120"/>
               </a:rPr>
-              <a:t>Convert each passage into a numerical vector that represents its meaning, so related text sits close together.</a:t>
+              <a:t>nomic-embed-text turns each passage into a 768-dimension vector, so passages with related meaning sit close together.</a:t>
             </a:r>
             <a:endParaRPr lang="en-US" sz="1150" dirty="0"/>
           </a:p>
@@ -10487,7 +11804,7 @@
                 <a:ea typeface="Calibri" pitchFamily="34" charset="-122"/>
                 <a:cs typeface="Calibri" pitchFamily="34" charset="-120"/>
               </a:rPr>
-              <a:t>Store every vector with its metadata — document name, page number and section — which is what makes a citation possible.</a:t>
+              <a:t>Each vector is saved with its document name, page and chunk index, next to a BM25 keyword index. Both are kept on disk.</a:t>
             </a:r>
             <a:endParaRPr lang="en-US" sz="1150" dirty="0"/>
           </a:p>
@@ -11060,7 +12377,7 @@
                 <a:ea typeface="Calibri" pitchFamily="34" charset="-122"/>
                 <a:cs typeface="Calibri" pitchFamily="34" charset="-120"/>
               </a:rPr>
-              <a:t>Semantic search</a:t>
+              <a:t>Hybrid search</a:t>
             </a:r>
             <a:endParaRPr lang="en-US" sz="1450" dirty="0"/>
           </a:p>
@@ -11099,7 +12416,7 @@
                 <a:ea typeface="Calibri" pitchFamily="34" charset="-122"/>
                 <a:cs typeface="Calibri" pitchFamily="34" charset="-120"/>
               </a:rPr>
-              <a:t>The query is embedded and compared against every stored passage</a:t>
+              <a:t>Vector similarity and BM25 keyword scores, merged by rank fusion</a:t>
             </a:r>
             <a:endParaRPr lang="en-US" sz="1150" dirty="0"/>
           </a:p>
@@ -11239,7 +12556,7 @@
                 <a:ea typeface="Calibri" pitchFamily="34" charset="-122"/>
                 <a:cs typeface="Calibri" pitchFamily="34" charset="-120"/>
               </a:rPr>
-              <a:t>Context retrieval</a:t>
+              <a:t>Reranking</a:t>
             </a:r>
             <a:endParaRPr lang="en-US" sz="1450" dirty="0"/>
           </a:p>
@@ -11278,7 +12595,7 @@
                 <a:ea typeface="Calibri" pitchFamily="34" charset="-122"/>
                 <a:cs typeface="Calibri" pitchFamily="34" charset="-120"/>
               </a:rPr>
-              <a:t>The best passages are selected — from one document or from several</a:t>
+              <a:t>A cross-encoder rescores 20 candidates and keeps the best 4</a:t>
             </a:r>
             <a:endParaRPr lang="en-US" sz="1150" dirty="0"/>
           </a:p>
@@ -11606,7 +12923,7 @@
                 <a:ea typeface="Calibri" pitchFamily="34" charset="-122"/>
                 <a:cs typeface="Calibri" pitchFamily="34" charset="-120"/>
               </a:rPr>
-              <a:t>Each sentence is linked back to the document and page that supports it</a:t>
+              <a:t>Each claim is tagged [Doc, Page]; one click opens the exact passage</a:t>
             </a:r>
             <a:endParaRPr lang="en-US" sz="1150" dirty="0"/>
           </a:p>
@@ -13716,7 +15033,7 @@
                 <a:ea typeface="Calibri" pitchFamily="34" charset="-122"/>
                 <a:cs typeface="Calibri" pitchFamily="34" charset="-120"/>
               </a:rPr>
-              <a:t>Programming language</a:t>
+              <a:t>Backend</a:t>
             </a:r>
             <a:endParaRPr lang="en-US" sz="1150" dirty="0"/>
           </a:p>
@@ -13755,7 +15072,7 @@
                 <a:ea typeface="Calibri" pitchFamily="34" charset="-122"/>
                 <a:cs typeface="Calibri" pitchFamily="34" charset="-120"/>
               </a:rPr>
-              <a:t>Python 3.11</a:t>
+              <a:t>Python 3.13 with FastAPI</a:t>
             </a:r>
             <a:endParaRPr lang="en-US" sz="1250" dirty="0"/>
           </a:p>
@@ -13833,7 +15150,7 @@
                 <a:ea typeface="Calibri" pitchFamily="34" charset="-122"/>
                 <a:cs typeface="Calibri" pitchFamily="34" charset="-120"/>
               </a:rPr>
-              <a:t>pdfplumber, pypdf</a:t>
+              <a:t>pdfplumber, pypdf, python-docx, Tesseract OCR</a:t>
             </a:r>
             <a:endParaRPr lang="en-US" sz="1250" dirty="0"/>
           </a:p>
@@ -13943,7 +15260,7 @@
                 <a:ea typeface="Calibri" pitchFamily="34" charset="-122"/>
                 <a:cs typeface="Calibri" pitchFamily="34" charset="-120"/>
               </a:rPr>
-              <a:t>Page-aware, sentence-boundary segmentation</a:t>
+              <a:t>800-character passages, 150 overlap, page-aware</a:t>
             </a:r>
             <a:endParaRPr lang="en-US" sz="1250" dirty="0"/>
           </a:p>
@@ -14021,7 +15338,7 @@
                 <a:ea typeface="Calibri" pitchFamily="34" charset="-122"/>
                 <a:cs typeface="Calibri" pitchFamily="34" charset="-120"/>
               </a:rPr>
-              <a:t>nomic-embed-text (runs locally)</a:t>
+              <a:t>nomic-embed-text, 768 dimensions (local)</a:t>
             </a:r>
             <a:endParaRPr lang="en-US" sz="1250" dirty="0"/>
           </a:p>
@@ -14092,7 +15409,7 @@
                 <a:ea typeface="Calibri" pitchFamily="34" charset="-122"/>
                 <a:cs typeface="Calibri" pitchFamily="34" charset="-120"/>
               </a:rPr>
-              <a:t>Vector database</a:t>
+              <a:t>Vector store</a:t>
             </a:r>
             <a:endParaRPr lang="en-US" sz="1150" dirty="0"/>
           </a:p>
@@ -14131,7 +15448,7 @@
                 <a:ea typeface="Calibri" pitchFamily="34" charset="-122"/>
                 <a:cs typeface="Calibri" pitchFamily="34" charset="-120"/>
               </a:rPr>
-              <a:t>ChromaDB / pgVector</a:t>
+              <a:t>NumPy vectors + BM25 index, saved to disk</a:t>
             </a:r>
             <a:endParaRPr lang="en-US" sz="1250" dirty="0"/>
           </a:p>
@@ -14209,7 +15526,7 @@
                 <a:ea typeface="Calibri" pitchFamily="34" charset="-122"/>
                 <a:cs typeface="Calibri" pitchFamily="34" charset="-120"/>
               </a:rPr>
-              <a:t>Semantic Search (Cosine Similarity)</a:t>
+              <a:t>Cosine + BM25, rank fusion, MiniLM reranker</a:t>
             </a:r>
             <a:endParaRPr lang="en-US" sz="1250" dirty="0"/>
           </a:p>
@@ -14319,7 +15636,7 @@
                 <a:ea typeface="Calibri" pitchFamily="34" charset="-122"/>
                 <a:cs typeface="Calibri" pitchFamily="34" charset="-120"/>
               </a:rPr>
-              <a:t>Qwen 2.5 7B served locally by Ollama</a:t>
+              <a:t>Qwen 2.5 7B on Ollama (Llama 3.1 8B in jury)</a:t>
             </a:r>
             <a:endParaRPr lang="en-US" sz="1250" dirty="0"/>
           </a:p>
@@ -14397,7 +15714,7 @@
                 <a:ea typeface="Calibri" pitchFamily="34" charset="-122"/>
                 <a:cs typeface="Calibri" pitchFamily="34" charset="-120"/>
               </a:rPr>
-              <a:t>React / Vite web application</a:t>
+              <a:t>React 18, TypeScript, Vite, Tailwind CSS</a:t>
             </a:r>
             <a:endParaRPr lang="en-US" sz="1250" dirty="0"/>
           </a:p>
@@ -14507,7 +15824,7 @@
                 <a:ea typeface="Calibri" pitchFamily="34" charset="-122"/>
                 <a:cs typeface="Calibri" pitchFamily="34" charset="-120"/>
               </a:rPr>
-              <a:t>Groundedness and citation-accuracy metrics</a:t>
+              <a:t>Claim audit, Hit@k and MRR self-tuning</a:t>
             </a:r>
             <a:endParaRPr lang="en-US" sz="1250" dirty="0"/>
           </a:p>
@@ -14815,7 +16132,7 @@
                 <a:ea typeface="Calibri" pitchFamily="34" charset="-122"/>
                 <a:cs typeface="Calibri" pitchFamily="34" charset="-120"/>
               </a:rPr>
-              <a:t>Receive context-based answers</a:t>
+              <a:t>Get streamed, cited answers</a:t>
             </a:r>
             <a:endParaRPr lang="en-US" sz="1250" dirty="0"/>
           </a:p>
@@ -14878,7 +16195,7 @@
                 <a:ea typeface="Calibri" pitchFamily="34" charset="-122"/>
                 <a:cs typeface="Calibri" pitchFamily="34" charset="-120"/>
               </a:rPr>
-              <a:t>View the supporting citations</a:t>
+              <a:t>Open the passage behind a citation</a:t>
             </a:r>
             <a:endParaRPr lang="en-US" sz="1250" dirty="0"/>
           </a:p>
@@ -15049,7 +16366,7 @@
                 <a:ea typeface="Calibri" pitchFamily="34" charset="-122"/>
                 <a:cs typeface="Calibri" pitchFamily="34" charset="-120"/>
               </a:rPr>
-              <a:t>The language model and the embedding model both run on the local machine through Ollama. No API keys, no cloud calls and no document ever leaves the laptop.</a:t>
+              <a:t>The language model, embeddings, reranker and speech-to-text all run on the local machine. No API keys, and no document ever leaves the laptop.</a:t>
             </a:r>
             <a:endParaRPr lang="en-US" sz="1100" dirty="0"/>
           </a:p>

</xml_diff>